<commit_message>
Aletração do logo Ruben e apresentação
</commit_message>
<xml_diff>
--- a/Apresentação/Poppy and Max.pptx
+++ b/Apresentação/Poppy and Max.pptx
@@ -5364,59 +5364,6 @@
       </p:sp>
       <p:sp>
         <p:nvSpPr>
-          <p:cNvPr id="7" name="Freeform 7"/>
-          <p:cNvSpPr/>
-          <p:nvPr/>
-        </p:nvSpPr>
-        <p:spPr>
-          <a:xfrm>
-            <a:off x="9965203" y="6866695"/>
-            <a:ext cx="3358334" cy="1456678"/>
-          </a:xfrm>
-          <a:custGeom>
-            <a:avLst/>
-            <a:gdLst/>
-            <a:ahLst/>
-            <a:cxnLst/>
-            <a:rect l="l" t="t" r="r" b="b"/>
-            <a:pathLst>
-              <a:path w="3358334" h="1456678">
-                <a:moveTo>
-                  <a:pt x="0" y="0"/>
-                </a:moveTo>
-                <a:lnTo>
-                  <a:pt x="3358335" y="0"/>
-                </a:lnTo>
-                <a:lnTo>
-                  <a:pt x="3358335" y="1456678"/>
-                </a:lnTo>
-                <a:lnTo>
-                  <a:pt x="0" y="1456678"/>
-                </a:lnTo>
-                <a:lnTo>
-                  <a:pt x="0" y="0"/>
-                </a:lnTo>
-                <a:close/>
-              </a:path>
-            </a:pathLst>
-          </a:custGeom>
-          <a:blipFill>
-            <a:blip r:embed="rId5"/>
-            <a:stretch>
-              <a:fillRect/>
-            </a:stretch>
-          </a:blipFill>
-        </p:spPr>
-        <p:txBody>
-          <a:bodyPr/>
-          <a:lstStyle/>
-          <a:p>
-            <a:endParaRPr lang="pt-PT"/>
-          </a:p>
-        </p:txBody>
-      </p:sp>
-      <p:sp>
-        <p:nvSpPr>
           <p:cNvPr id="8" name="Freeform 8"/>
           <p:cNvSpPr/>
           <p:nvPr/>
@@ -5457,7 +5404,7 @@
             <a:blip>
               <a:extLst>
                 <a:ext uri="{96DAC541-7B7A-43D3-8B79-37D633B846F1}">
-                  <asvg:svgBlip xmlns:asvg="http://schemas.microsoft.com/office/drawing/2016/SVG/main" r:embed="rId6"/>
+                  <asvg:svgBlip xmlns:asvg="http://schemas.microsoft.com/office/drawing/2016/SVG/main" r:embed="rId5"/>
                 </a:ext>
               </a:extLst>
             </a:blip>
@@ -5513,7 +5460,7 @@
             </a:pathLst>
           </a:custGeom>
           <a:blipFill>
-            <a:blip r:embed="rId7"/>
+            <a:blip r:embed="rId6"/>
             <a:stretch>
               <a:fillRect/>
             </a:stretch>
@@ -5566,7 +5513,7 @@
             </a:pathLst>
           </a:custGeom>
           <a:blipFill>
-            <a:blip r:embed="rId8"/>
+            <a:blip r:embed="rId7"/>
             <a:stretch>
               <a:fillRect l="-48651" t="-39178" r="-38172" b="-29721"/>
             </a:stretch>
@@ -5938,6 +5885,42 @@
           </a:p>
         </p:txBody>
       </p:sp>
+      <p:pic>
+        <p:nvPicPr>
+          <p:cNvPr id="20" name="Imagem 19">
+            <a:extLst>
+              <a:ext uri="{FF2B5EF4-FFF2-40B4-BE49-F238E27FC236}">
+                <a16:creationId xmlns:a16="http://schemas.microsoft.com/office/drawing/2014/main" id="{D37A5F0F-8260-F7AA-F7F2-91A4BF64AD42}"/>
+              </a:ext>
+            </a:extLst>
+          </p:cNvPr>
+          <p:cNvPicPr>
+            <a:picLocks noChangeAspect="1"/>
+          </p:cNvPicPr>
+          <p:nvPr/>
+        </p:nvPicPr>
+        <p:blipFill>
+          <a:blip r:embed="rId8" cstate="print">
+            <a:extLst>
+              <a:ext uri="{28A0092B-C50C-407E-A947-70E740481C1C}">
+                <a14:useLocalDpi xmlns:a14="http://schemas.microsoft.com/office/drawing/2010/main" val="0"/>
+              </a:ext>
+            </a:extLst>
+          </a:blip>
+          <a:stretch>
+            <a:fillRect/>
+          </a:stretch>
+        </p:blipFill>
+        <p:spPr>
+          <a:xfrm>
+            <a:off x="9962443" y="6896100"/>
+            <a:ext cx="3657607" cy="1584963"/>
+          </a:xfrm>
+          <a:prstGeom prst="rect">
+            <a:avLst/>
+          </a:prstGeom>
+        </p:spPr>
+      </p:pic>
     </p:spTree>
   </p:cSld>
   <p:clrMapOvr>

</xml_diff>